<commit_message>
Deploy PSYCH 350 RC37 protected-ta-guide 2026-09-03
</commit_message>
<xml_diff>
--- a/lab-materials/lab03/files/lab03_reading_slides.pptx
+++ b/lab-materials/lab03/files/lab03_reading_slides.pptx
@@ -735,10 +735,7 @@
               <a:buNone/>
               <a:defRPr sz="2000">
                 <a:solidFill>
-                  <a:schemeClr val="tx1">
-                    <a:lumMod val="75000"/>
-                    <a:lumOff val="25000"/>
-                  </a:schemeClr>
+                  <a:srgbClr val="FFFFFF"/>
                 </a:solidFill>
               </a:defRPr>
             </a:lvl1pPr>
@@ -4708,7 +4705,7 @@
       </p:sp>
       <p:graphicFrame xmlns:a="http://schemas.openxmlformats.org/drawingml/2006/main" xmlns:r="http://schemas.openxmlformats.org/officeDocument/2006/relationships" xmlns:p="http://schemas.openxmlformats.org/presentationml/2006/main">
         <p:nvGraphicFramePr>
-          <p:cNvPr id="790630756" name=""/>
+          <p:cNvPr id="729723705" name=""/>
           <p:cNvGraphicFramePr>
             <a:graphicFrameLocks noGrp="true"/>
           </p:cNvGraphicFramePr>
@@ -6105,7 +6102,7 @@
       </p:sp>
       <p:graphicFrame xmlns:a="http://schemas.openxmlformats.org/drawingml/2006/main" xmlns:r="http://schemas.openxmlformats.org/officeDocument/2006/relationships" xmlns:p="http://schemas.openxmlformats.org/presentationml/2006/main">
         <p:nvGraphicFramePr>
-          <p:cNvPr id="96797875" name=""/>
+          <p:cNvPr id="456311802" name=""/>
           <p:cNvGraphicFramePr>
             <a:graphicFrameLocks noGrp="true"/>
           </p:cNvGraphicFramePr>

</xml_diff>